<commit_message>
Slider- Update Slider data
</commit_message>
<xml_diff>
--- a/.lessons/54 Slider Features/7 Slider- Update Slider data/1.pptx
+++ b/.lessons/54 Slider Features/7 Slider- Update Slider data/1.pptx
@@ -6,8 +6,14 @@
   </p:sldMasterIdLst>
   <p:sldIdLst>
     <p:sldId id="413" r:id="rId2"/>
-    <p:sldId id="414" r:id="rId3"/>
-    <p:sldId id="400" r:id="rId4"/>
+    <p:sldId id="415" r:id="rId3"/>
+    <p:sldId id="416" r:id="rId4"/>
+    <p:sldId id="417" r:id="rId5"/>
+    <p:sldId id="414" r:id="rId6"/>
+    <p:sldId id="418" r:id="rId7"/>
+    <p:sldId id="419" r:id="rId8"/>
+    <p:sldId id="420" r:id="rId9"/>
+    <p:sldId id="400" r:id="rId10"/>
   </p:sldIdLst>
   <p:sldSz cx="12192000" cy="6858000"/>
   <p:notesSz cx="6858000" cy="9144000"/>
@@ -114,6 +120,90 @@
 </p:presentation>
 </file>
 
+<file path=ppt/ink/ink1.xml><?xml version="1.0" encoding="utf-8"?>
+<inkml:ink xmlns:inkml="http://www.w3.org/2003/InkML">
+  <inkml:definitions>
+    <inkml:context xml:id="ctx0">
+      <inkml:inkSource xml:id="inkSrc0">
+        <inkml:traceFormat>
+          <inkml:channel name="X" type="integer" min="-2.14748E9" max="2.14748E9" units="cm"/>
+          <inkml:channel name="Y" type="integer" min="-2.14748E9" max="2.14748E9" units="cm"/>
+          <inkml:channel name="F" type="integer" max="32767" units="dev"/>
+        </inkml:traceFormat>
+        <inkml:channelProperties>
+          <inkml:channelProperty channel="X" name="resolution" value="1000" units="1/cm"/>
+          <inkml:channelProperty channel="Y" name="resolution" value="1000" units="1/cm"/>
+          <inkml:channelProperty channel="F" name="resolution" value="0" units="1/dev"/>
+        </inkml:channelProperties>
+      </inkml:inkSource>
+      <inkml:timestamp xml:id="ts0" timeString="2025-08-07T14:49:53.620"/>
+    </inkml:context>
+    <inkml:brush xml:id="br0">
+      <inkml:brushProperty name="width" value="0.035" units="cm"/>
+      <inkml:brushProperty name="height" value="0.035" units="cm"/>
+      <inkml:brushProperty name="color" value="#E71224"/>
+    </inkml:brush>
+  </inkml:definitions>
+  <inkml:trace contextRef="#ctx0" brushRef="#br0">1 870 24575,'8'-11'0,"1"-1"0,0 2 0,1-1 0,0 1 0,0 0 0,1 1 0,1 1 0,-1-1 0,19-8 0,21-18 0,65-50 0,-12 9 0,134-126 0,-198 157 0,-2-1 0,-2-1 0,-2-2 0,45-88 0,-51 101 0,-28 36 0,1-1 0,-1 1 0,0-1 0,1 1 0,-1 0 0,1-1 0,-1 1 0,1 0 0,-1 0 0,1-1 0,-1 1 0,1 0 0,-1 0 0,1 0 0,-1-1 0,1 1 0,-1 0 0,1 0 0,-1 0 0,1 0 0,-1 0 0,1 0 0,-1 0 0,1 0 0,0 1 0,0-1 0,-1 1 0,1 0 0,0 0 0,-1 0 0,1 0 0,-1 0 0,1 0 0,-1 0 0,1 0 0,-1 1 0,0-1 0,0 0 0,1 0 0,-1 0 0,0 0 0,0 1 0,0-1 0,-1 0 0,1 2 0,-4 35 0,-2-1 0,-2 1 0,-1-2 0,-23 61 0,2-6 0,-42 147 0,-75 276 0,111-366 0,-36 175 0,52-209 0,-12 85 0,26-160-1365,1-7-5461</inkml:trace>
+</inkml:ink>
+</file>
+
+<file path=ppt/ink/ink2.xml><?xml version="1.0" encoding="utf-8"?>
+<inkml:ink xmlns:inkml="http://www.w3.org/2003/InkML">
+  <inkml:definitions>
+    <inkml:context xml:id="ctx0">
+      <inkml:inkSource xml:id="inkSrc0">
+        <inkml:traceFormat>
+          <inkml:channel name="X" type="integer" min="-2.14748E9" max="2.14748E9" units="cm"/>
+          <inkml:channel name="Y" type="integer" min="-2.14748E9" max="2.14748E9" units="cm"/>
+          <inkml:channel name="F" type="integer" max="32767" units="dev"/>
+        </inkml:traceFormat>
+        <inkml:channelProperties>
+          <inkml:channelProperty channel="X" name="resolution" value="1000" units="1/cm"/>
+          <inkml:channelProperty channel="Y" name="resolution" value="1000" units="1/cm"/>
+          <inkml:channelProperty channel="F" name="resolution" value="0" units="1/dev"/>
+        </inkml:channelProperties>
+      </inkml:inkSource>
+      <inkml:timestamp xml:id="ts0" timeString="2025-08-07T14:49:58.586"/>
+    </inkml:context>
+    <inkml:brush xml:id="br0">
+      <inkml:brushProperty name="width" value="0.035" units="cm"/>
+      <inkml:brushProperty name="height" value="0.035" units="cm"/>
+      <inkml:brushProperty name="color" value="#E71224"/>
+    </inkml:brush>
+  </inkml:definitions>
+  <inkml:trace contextRef="#ctx0" brushRef="#br0">60 227 24575,'10'-7'0,"1"0"0,-2-1 0,1-1 0,-1 0 0,-1 0 0,1 0 0,-1-1 0,8-14 0,19-22 0,-26 36 0,1 0 0,0 0 0,1 1 0,0 0 0,0 1 0,23-13 0,-31 20 0,0-1 0,1 0 0,-1 1 0,0 0 0,1 0 0,-1 0 0,1 0 0,0 0 0,-1 1 0,1-1 0,-1 1 0,1 0 0,0 0 0,-1 1 0,1-1 0,0 1 0,-1 0 0,1-1 0,-1 2 0,0-1 0,1 0 0,-1 1 0,0-1 0,1 1 0,-1 0 0,0 0 0,-1 0 0,1 1 0,0-1 0,0 1 0,1 2 0,2 3 0,0 0 0,-1 0 0,-1 0 0,0 0 0,0 1 0,0 0 0,-1 0 0,3 12 0,10 78 0,-13-74 0,16 227 0,-13 293 0,-9-344 0,-15 190 0,10-325 0,-4-1 0,-2 1 0,-42 116 0,44-147 0,-3 0 0,-1-1 0,-1-1 0,-2-1 0,-1-1 0,-48 58 0,65-86 0,0 1 0,-1-1 0,1 0 0,-1-1 0,0 1 0,0 0 0,0-1 0,0 0 0,0 0 0,0 0 0,-1-1 0,1 1 0,-1-1 0,1 0 0,-8 0 0,9-1 0,-1 0 0,0 0 0,1-1 0,-1 0 0,1 0 0,0 0 0,-1 0 0,1 0 0,0-1 0,-1 1 0,1-1 0,0 0 0,0 0 0,0 0 0,1 0 0,-1-1 0,0 1 0,1-1 0,0 0 0,-4-4 0,-1-5 0,0 0 0,0 0 0,1-1 0,1 0 0,0 0 0,1 0 0,0-1 0,1 1 0,-2-29 0,1-12 0,4-66 0,1 83 0,-1 13 0,1 0 0,1 0 0,1 1 0,1-1 0,8-25 0,-9 40 0,1 0 0,-1 1 0,2 0 0,-1-1 0,1 2 0,1-1 0,-1 0 0,1 1 0,0 0 0,1 1 0,0-1 0,0 1 0,0 0 0,1 1 0,16-9 0,-16 9 0,0 1 0,1 0 0,0 1 0,0 0 0,0 0 0,0 1 0,15-1 0,-20 2 0,1 1 0,0 0 0,0 1 0,-1-1 0,1 1 0,0 0 0,-1 0 0,1 0 0,-1 1 0,1 0 0,-1-1 0,0 2 0,1-1 0,-1 0 0,0 1 0,-1 0 0,5 3 0,9 11 0,-1 0 0,-1 2 0,0-1 0,-2 2 0,21 38 0,47 118 0,-52-106 0,75 186-1365,-89-224-5461</inkml:trace>
+</inkml:ink>
+</file>
+
+<file path=ppt/ink/ink3.xml><?xml version="1.0" encoding="utf-8"?>
+<inkml:ink xmlns:inkml="http://www.w3.org/2003/InkML">
+  <inkml:definitions>
+    <inkml:context xml:id="ctx0">
+      <inkml:inkSource xml:id="inkSrc0">
+        <inkml:traceFormat>
+          <inkml:channel name="X" type="integer" min="-2.14748E9" max="2.14748E9" units="cm"/>
+          <inkml:channel name="Y" type="integer" min="-2.14748E9" max="2.14748E9" units="cm"/>
+          <inkml:channel name="F" type="integer" max="32767" units="dev"/>
+        </inkml:traceFormat>
+        <inkml:channelProperties>
+          <inkml:channelProperty channel="X" name="resolution" value="1000" units="1/cm"/>
+          <inkml:channelProperty channel="Y" name="resolution" value="1000" units="1/cm"/>
+          <inkml:channelProperty channel="F" name="resolution" value="0" units="1/dev"/>
+        </inkml:channelProperties>
+      </inkml:inkSource>
+      <inkml:timestamp xml:id="ts0" timeString="2025-08-07T14:50:00.730"/>
+    </inkml:context>
+    <inkml:brush xml:id="br0">
+      <inkml:brushProperty name="width" value="0.035" units="cm"/>
+      <inkml:brushProperty name="height" value="0.035" units="cm"/>
+      <inkml:brushProperty name="color" value="#E71224"/>
+    </inkml:brush>
+  </inkml:definitions>
+  <inkml:trace contextRef="#ctx0" brushRef="#br0">172 2 24575,'95'-1'0,"108"3"0,-196-2 0,-1 1 0,1 1 0,-1-1 0,0 1 0,1 0 0,-1 1 0,0-1 0,0 1 0,0 0 0,-1 1 0,1 0 0,-1-1 0,0 2 0,0-1 0,8 10 0,3 5 0,0 1 0,22 41 0,-19-30 0,5 6 0,-3 0 0,0 1 0,-3 1 0,18 52 0,-32-79 0,-1-1 0,0 1 0,-1 0 0,0 0 0,-1 0 0,0 0 0,-1 1 0,0-1 0,-1 0 0,0 0 0,-1 0 0,-1 0 0,0-1 0,0 1 0,-1 0 0,0-1 0,-1 0 0,-1 0 0,0-1 0,-8 12 0,0-5 0,0 0 0,-1-1 0,-1-1 0,-1 0 0,0-2 0,-1 0 0,0 0 0,-35 16 0,1-6 0,-1-2 0,-63 16 0,96-30 0,17-3 0,26 1 0,4-1 0,-17-1 0,1 1 0,-1 1 0,1 0 0,-1 0 0,-1 1 0,1 0 0,-1 1 0,16 14 0,-5-2 0,-1 2 0,25 31 0,-35-38 0,0 1 0,-1-1 0,-1 1 0,0 1 0,-1-1 0,7 28 0,15 106 0,-15-72 0,-8-49 0,19 115 0,-22-123 0,-1 0 0,0 0 0,-2 0 0,-6 40 0,6-56 0,0 0 0,-1 0 0,1 0 0,-1 0 0,0 0 0,-1 0 0,1-1 0,0 1 0,-1-1 0,0 0 0,0 0 0,0 0 0,0 0 0,-1 0 0,1 0 0,-1-1 0,1 0 0,-1 0 0,0 0 0,0 0 0,0 0 0,0-1 0,0 0 0,-6 1 0,-12 3 0,-1-1 0,-1-1 0,-31 0 0,21-2 0,-311 4-362,277-5-641,37-1-5823</inkml:trace>
+</inkml:ink>
+</file>
+
 <file path=ppt/slideLayouts/slideLayout1.xml><?xml version="1.0" encoding="utf-8"?>
 <p:sldLayout xmlns:a="http://schemas.openxmlformats.org/drawingml/2006/main" xmlns:r="http://schemas.openxmlformats.org/officeDocument/2006/relationships" xmlns:p="http://schemas.openxmlformats.org/presentationml/2006/main" type="title" preserve="1">
   <p:cSld name="Title Slide">
@@ -261,7 +351,7 @@
           <a:p>
             <a:fld id="{3E102D2E-813C-461C-9963-687A650C48C0}" type="datetimeFigureOut">
               <a:rPr lang="en-US" smtClean="0"/>
-              <a:t>6/26/2025</a:t>
+              <a:t>8/7/2025</a:t>
             </a:fld>
             <a:endParaRPr lang="en-US"/>
           </a:p>
@@ -459,7 +549,7 @@
           <a:p>
             <a:fld id="{3E102D2E-813C-461C-9963-687A650C48C0}" type="datetimeFigureOut">
               <a:rPr lang="en-US" smtClean="0"/>
-              <a:t>6/26/2025</a:t>
+              <a:t>8/7/2025</a:t>
             </a:fld>
             <a:endParaRPr lang="en-US"/>
           </a:p>
@@ -667,7 +757,7 @@
           <a:p>
             <a:fld id="{3E102D2E-813C-461C-9963-687A650C48C0}" type="datetimeFigureOut">
               <a:rPr lang="en-US" smtClean="0"/>
-              <a:t>6/26/2025</a:t>
+              <a:t>8/7/2025</a:t>
             </a:fld>
             <a:endParaRPr lang="en-US"/>
           </a:p>
@@ -865,7 +955,7 @@
           <a:p>
             <a:fld id="{3E102D2E-813C-461C-9963-687A650C48C0}" type="datetimeFigureOut">
               <a:rPr lang="en-US" smtClean="0"/>
-              <a:t>6/26/2025</a:t>
+              <a:t>8/7/2025</a:t>
             </a:fld>
             <a:endParaRPr lang="en-US"/>
           </a:p>
@@ -1140,7 +1230,7 @@
           <a:p>
             <a:fld id="{3E102D2E-813C-461C-9963-687A650C48C0}" type="datetimeFigureOut">
               <a:rPr lang="en-US" smtClean="0"/>
-              <a:t>6/26/2025</a:t>
+              <a:t>8/7/2025</a:t>
             </a:fld>
             <a:endParaRPr lang="en-US"/>
           </a:p>
@@ -1405,7 +1495,7 @@
           <a:p>
             <a:fld id="{3E102D2E-813C-461C-9963-687A650C48C0}" type="datetimeFigureOut">
               <a:rPr lang="en-US" smtClean="0"/>
-              <a:t>6/26/2025</a:t>
+              <a:t>8/7/2025</a:t>
             </a:fld>
             <a:endParaRPr lang="en-US"/>
           </a:p>
@@ -1817,7 +1907,7 @@
           <a:p>
             <a:fld id="{3E102D2E-813C-461C-9963-687A650C48C0}" type="datetimeFigureOut">
               <a:rPr lang="en-US" smtClean="0"/>
-              <a:t>6/26/2025</a:t>
+              <a:t>8/7/2025</a:t>
             </a:fld>
             <a:endParaRPr lang="en-US"/>
           </a:p>
@@ -1958,7 +2048,7 @@
           <a:p>
             <a:fld id="{3E102D2E-813C-461C-9963-687A650C48C0}" type="datetimeFigureOut">
               <a:rPr lang="en-US" smtClean="0"/>
-              <a:t>6/26/2025</a:t>
+              <a:t>8/7/2025</a:t>
             </a:fld>
             <a:endParaRPr lang="en-US"/>
           </a:p>
@@ -2071,7 +2161,7 @@
           <a:p>
             <a:fld id="{3E102D2E-813C-461C-9963-687A650C48C0}" type="datetimeFigureOut">
               <a:rPr lang="en-US" smtClean="0"/>
-              <a:t>6/26/2025</a:t>
+              <a:t>8/7/2025</a:t>
             </a:fld>
             <a:endParaRPr lang="en-US"/>
           </a:p>
@@ -2382,7 +2472,7 @@
           <a:p>
             <a:fld id="{3E102D2E-813C-461C-9963-687A650C48C0}" type="datetimeFigureOut">
               <a:rPr lang="en-US" smtClean="0"/>
-              <a:t>6/26/2025</a:t>
+              <a:t>8/7/2025</a:t>
             </a:fld>
             <a:endParaRPr lang="en-US"/>
           </a:p>
@@ -2670,7 +2760,7 @@
           <a:p>
             <a:fld id="{3E102D2E-813C-461C-9963-687A650C48C0}" type="datetimeFigureOut">
               <a:rPr lang="en-US" smtClean="0"/>
-              <a:t>6/26/2025</a:t>
+              <a:t>8/7/2025</a:t>
             </a:fld>
             <a:endParaRPr lang="en-US"/>
           </a:p>
@@ -2911,7 +3001,7 @@
           <a:p>
             <a:fld id="{3E102D2E-813C-461C-9963-687A650C48C0}" type="datetimeFigureOut">
               <a:rPr lang="en-US" smtClean="0"/>
-              <a:t>6/26/2025</a:t>
+              <a:t>8/7/2025</a:t>
             </a:fld>
             <a:endParaRPr lang="en-US"/>
           </a:p>
@@ -3348,8 +3438,8 @@
         </p:nvSpPr>
         <p:spPr>
           <a:xfrm>
-            <a:off x="217714" y="255046"/>
-            <a:ext cx="11756571" cy="355354"/>
+            <a:off x="184728" y="55416"/>
+            <a:ext cx="11789558" cy="355354"/>
           </a:xfrm>
           <a:prstGeom prst="rect">
             <a:avLst/>
@@ -3369,21 +3459,261 @@
               <a:buNone/>
             </a:pPr>
             <a:r>
-              <a:rPr kumimoji="0" lang="en-US" altLang="en-US" sz="1300" b="0" i="0" u="none" strike="noStrike" cap="none" normalizeH="0" baseline="0">
-                <a:ln>
-                  <a:noFill/>
-                </a:ln>
-                <a:solidFill>
-                  <a:schemeClr val="tx1"/>
-                </a:solidFill>
-                <a:effectLst/>
-                <a:latin typeface="Arial" panose="020B0604020202020204" pitchFamily="34" charset="0"/>
-              </a:rPr>
-              <a:t>.</a:t>
-            </a:r>
-          </a:p>
-        </p:txBody>
-      </p:sp>
+              <a:rPr lang="az-Latn-AZ" altLang="en-US" sz="1300" b="1">
+                <a:latin typeface="Arial" panose="020B0604020202020204" pitchFamily="34" charset="0"/>
+              </a:rPr>
+              <a:t>EDİT</a:t>
+            </a:r>
+            <a:r>
+              <a:rPr lang="az-Latn-AZ" altLang="en-US" sz="1300">
+                <a:latin typeface="Arial" panose="020B0604020202020204" pitchFamily="34" charset="0"/>
+              </a:rPr>
+              <a:t> düyməsini kliklədikdə açılacaq </a:t>
+            </a:r>
+            <a:r>
+              <a:rPr lang="az-Latn-AZ" altLang="en-US" sz="1300" b="1">
+                <a:latin typeface="Arial" panose="020B0604020202020204" pitchFamily="34" charset="0"/>
+              </a:rPr>
+              <a:t>şablonu</a:t>
+            </a:r>
+            <a:r>
+              <a:rPr lang="az-Latn-AZ" altLang="en-US" sz="1300">
+                <a:latin typeface="Arial" panose="020B0604020202020204" pitchFamily="34" charset="0"/>
+              </a:rPr>
+              <a:t> redakdə edirik. </a:t>
+            </a:r>
+            <a:r>
+              <a:rPr lang="az-Latn-AZ" altLang="en-US" sz="1300" b="1">
+                <a:latin typeface="Arial" panose="020B0604020202020204" pitchFamily="34" charset="0"/>
+              </a:rPr>
+              <a:t>create</a:t>
+            </a:r>
+            <a:r>
+              <a:rPr lang="az-Latn-AZ" altLang="en-US" sz="1300">
+                <a:latin typeface="Arial" panose="020B0604020202020204" pitchFamily="34" charset="0"/>
+              </a:rPr>
+              <a:t> faylını </a:t>
+            </a:r>
+            <a:r>
+              <a:rPr lang="az-Latn-AZ" altLang="en-US" sz="1300" b="1">
+                <a:latin typeface="Arial" panose="020B0604020202020204" pitchFamily="34" charset="0"/>
+              </a:rPr>
+              <a:t>edit</a:t>
+            </a:r>
+            <a:r>
+              <a:rPr lang="az-Latn-AZ" altLang="en-US" sz="1300">
+                <a:latin typeface="Arial" panose="020B0604020202020204" pitchFamily="34" charset="0"/>
+              </a:rPr>
+              <a:t> faylına kopyalayırı və kontrollerə </a:t>
+            </a:r>
+            <a:r>
+              <a:rPr lang="en-US" altLang="en-US" sz="1300" b="1">
+                <a:latin typeface="Arial" panose="020B0604020202020204" pitchFamily="34" charset="0"/>
+              </a:rPr>
+              <a:t>view() </a:t>
+            </a:r>
+            <a:r>
+              <a:rPr lang="az-Latn-AZ" altLang="en-US" sz="1300">
+                <a:latin typeface="Arial" panose="020B0604020202020204" pitchFamily="34" charset="0"/>
+              </a:rPr>
+              <a:t>əlavə edirik.</a:t>
+            </a:r>
+            <a:endParaRPr kumimoji="0" lang="en-US" altLang="en-US" sz="1300" b="0" i="0" u="none" strike="noStrike" cap="none" normalizeH="0" baseline="0">
+              <a:ln>
+                <a:noFill/>
+              </a:ln>
+              <a:solidFill>
+                <a:schemeClr val="tx1"/>
+              </a:solidFill>
+              <a:effectLst/>
+              <a:latin typeface="Arial" panose="020B0604020202020204" pitchFamily="34" charset="0"/>
+            </a:endParaRPr>
+          </a:p>
+        </p:txBody>
+      </p:sp>
+      <p:pic>
+        <p:nvPicPr>
+          <p:cNvPr id="4" name="Picture 3">
+            <a:extLst>
+              <a:ext uri="{FF2B5EF4-FFF2-40B4-BE49-F238E27FC236}">
+                <a16:creationId xmlns:a16="http://schemas.microsoft.com/office/drawing/2014/main" id="{2336CFDF-1268-5030-E27E-9898D4A1046D}"/>
+              </a:ext>
+            </a:extLst>
+          </p:cNvPr>
+          <p:cNvPicPr>
+            <a:picLocks noChangeAspect="1"/>
+          </p:cNvPicPr>
+          <p:nvPr/>
+        </p:nvPicPr>
+        <p:blipFill>
+          <a:blip r:embed="rId2"/>
+          <a:stretch>
+            <a:fillRect/>
+          </a:stretch>
+        </p:blipFill>
+        <p:spPr>
+          <a:xfrm>
+            <a:off x="0" y="466141"/>
+            <a:ext cx="12192000" cy="6391859"/>
+          </a:xfrm>
+          <a:prstGeom prst="rect">
+            <a:avLst/>
+          </a:prstGeom>
+        </p:spPr>
+      </p:pic>
+      <mc:AlternateContent xmlns:mc="http://schemas.openxmlformats.org/markup-compatibility/2006">
+        <mc:Choice xmlns:p14="http://schemas.microsoft.com/office/powerpoint/2010/main" Requires="p14">
+          <p:contentPart p14:bwMode="auto" r:id="rId3">
+            <p14:nvContentPartPr>
+              <p14:cNvPr id="5" name="Ink 4">
+                <a:extLst>
+                  <a:ext uri="{FF2B5EF4-FFF2-40B4-BE49-F238E27FC236}">
+                    <a16:creationId xmlns:a16="http://schemas.microsoft.com/office/drawing/2014/main" id="{FF0357EA-0495-B0C1-D16B-6088E23B7C1A}"/>
+                  </a:ext>
+                </a:extLst>
+              </p14:cNvPr>
+              <p14:cNvContentPartPr/>
+              <p14:nvPr/>
+            </p14:nvContentPartPr>
+            <p14:xfrm>
+              <a:off x="2687433" y="4138738"/>
+              <a:ext cx="325800" cy="708840"/>
+            </p14:xfrm>
+          </p:contentPart>
+        </mc:Choice>
+        <mc:Fallback>
+          <p:pic>
+            <p:nvPicPr>
+              <p:cNvPr id="5" name="Ink 4">
+                <a:extLst>
+                  <a:ext uri="{FF2B5EF4-FFF2-40B4-BE49-F238E27FC236}">
+                    <a16:creationId xmlns:a16="http://schemas.microsoft.com/office/drawing/2014/main" id="{FF0357EA-0495-B0C1-D16B-6088E23B7C1A}"/>
+                  </a:ext>
+                </a:extLst>
+              </p:cNvPr>
+              <p:cNvPicPr/>
+              <p:nvPr/>
+            </p:nvPicPr>
+            <p:blipFill>
+              <a:blip r:embed="rId4"/>
+              <a:stretch>
+                <a:fillRect/>
+              </a:stretch>
+            </p:blipFill>
+            <p:spPr>
+              <a:xfrm>
+                <a:off x="2681313" y="4132618"/>
+                <a:ext cx="338040" cy="721080"/>
+              </a:xfrm>
+              <a:prstGeom prst="rect">
+                <a:avLst/>
+              </a:prstGeom>
+            </p:spPr>
+          </p:pic>
+        </mc:Fallback>
+      </mc:AlternateContent>
+      <mc:AlternateContent xmlns:mc="http://schemas.openxmlformats.org/markup-compatibility/2006">
+        <mc:Choice xmlns:p14="http://schemas.microsoft.com/office/powerpoint/2010/main" Requires="p14">
+          <p:contentPart p14:bwMode="auto" r:id="rId5">
+            <p14:nvContentPartPr>
+              <p14:cNvPr id="6" name="Ink 5">
+                <a:extLst>
+                  <a:ext uri="{FF2B5EF4-FFF2-40B4-BE49-F238E27FC236}">
+                    <a16:creationId xmlns:a16="http://schemas.microsoft.com/office/drawing/2014/main" id="{4485669A-5267-9B88-4BBA-F626AD5C955A}"/>
+                  </a:ext>
+                </a:extLst>
+              </p14:cNvPr>
+              <p14:cNvContentPartPr/>
+              <p14:nvPr/>
+            </p14:nvContentPartPr>
+            <p14:xfrm>
+              <a:off x="5141553" y="3852898"/>
+              <a:ext cx="229680" cy="840960"/>
+            </p14:xfrm>
+          </p:contentPart>
+        </mc:Choice>
+        <mc:Fallback>
+          <p:pic>
+            <p:nvPicPr>
+              <p:cNvPr id="6" name="Ink 5">
+                <a:extLst>
+                  <a:ext uri="{FF2B5EF4-FFF2-40B4-BE49-F238E27FC236}">
+                    <a16:creationId xmlns:a16="http://schemas.microsoft.com/office/drawing/2014/main" id="{4485669A-5267-9B88-4BBA-F626AD5C955A}"/>
+                  </a:ext>
+                </a:extLst>
+              </p:cNvPr>
+              <p:cNvPicPr/>
+              <p:nvPr/>
+            </p:nvPicPr>
+            <p:blipFill>
+              <a:blip r:embed="rId6"/>
+              <a:stretch>
+                <a:fillRect/>
+              </a:stretch>
+            </p:blipFill>
+            <p:spPr>
+              <a:xfrm>
+                <a:off x="5135433" y="3846778"/>
+                <a:ext cx="241920" cy="853200"/>
+              </a:xfrm>
+              <a:prstGeom prst="rect">
+                <a:avLst/>
+              </a:prstGeom>
+            </p:spPr>
+          </p:pic>
+        </mc:Fallback>
+      </mc:AlternateContent>
+      <mc:AlternateContent xmlns:mc="http://schemas.openxmlformats.org/markup-compatibility/2006">
+        <mc:Choice xmlns:p14="http://schemas.microsoft.com/office/powerpoint/2010/main" Requires="p14">
+          <p:contentPart p14:bwMode="auto" r:id="rId7">
+            <p14:nvContentPartPr>
+              <p14:cNvPr id="7" name="Ink 6">
+                <a:extLst>
+                  <a:ext uri="{FF2B5EF4-FFF2-40B4-BE49-F238E27FC236}">
+                    <a16:creationId xmlns:a16="http://schemas.microsoft.com/office/drawing/2014/main" id="{EFF5C0ED-5243-9A7F-9509-A840A90E9A5C}"/>
+                  </a:ext>
+                </a:extLst>
+              </p14:cNvPr>
+              <p14:cNvContentPartPr/>
+              <p14:nvPr/>
+            </p14:nvContentPartPr>
+            <p14:xfrm>
+              <a:off x="11695713" y="3730858"/>
+              <a:ext cx="286920" cy="666000"/>
+            </p14:xfrm>
+          </p:contentPart>
+        </mc:Choice>
+        <mc:Fallback>
+          <p:pic>
+            <p:nvPicPr>
+              <p:cNvPr id="7" name="Ink 6">
+                <a:extLst>
+                  <a:ext uri="{FF2B5EF4-FFF2-40B4-BE49-F238E27FC236}">
+                    <a16:creationId xmlns:a16="http://schemas.microsoft.com/office/drawing/2014/main" id="{EFF5C0ED-5243-9A7F-9509-A840A90E9A5C}"/>
+                  </a:ext>
+                </a:extLst>
+              </p:cNvPr>
+              <p:cNvPicPr/>
+              <p:nvPr/>
+            </p:nvPicPr>
+            <p:blipFill>
+              <a:blip r:embed="rId8"/>
+              <a:stretch>
+                <a:fillRect/>
+              </a:stretch>
+            </p:blipFill>
+            <p:spPr>
+              <a:xfrm>
+                <a:off x="11689593" y="3724738"/>
+                <a:ext cx="299160" cy="678240"/>
+              </a:xfrm>
+              <a:prstGeom prst="rect">
+                <a:avLst/>
+              </a:prstGeom>
+            </p:spPr>
+          </p:pic>
+        </mc:Fallback>
+      </mc:AlternateContent>
     </p:spTree>
     <p:extLst>
       <p:ext uri="{BB962C8B-B14F-4D97-AF65-F5344CB8AC3E}">
@@ -3398,6 +3728,461 @@
 </file>
 
 <file path=ppt/slides/slide2.xml><?xml version="1.0" encoding="utf-8"?>
+<p:sld xmlns:a="http://schemas.openxmlformats.org/drawingml/2006/main" xmlns:r="http://schemas.openxmlformats.org/officeDocument/2006/relationships" xmlns:p="http://schemas.openxmlformats.org/presentationml/2006/main">
+  <p:cSld>
+    <p:spTree>
+      <p:nvGrpSpPr>
+        <p:cNvPr id="1" name="">
+          <a:extLst>
+            <a:ext uri="{FF2B5EF4-FFF2-40B4-BE49-F238E27FC236}">
+              <a16:creationId xmlns:a16="http://schemas.microsoft.com/office/drawing/2014/main" id="{41E636DA-6778-73BA-124C-A10453C36BC9}"/>
+            </a:ext>
+          </a:extLst>
+        </p:cNvPr>
+        <p:cNvGrpSpPr/>
+        <p:nvPr/>
+      </p:nvGrpSpPr>
+      <p:grpSpPr>
+        <a:xfrm>
+          <a:off x="0" y="0"/>
+          <a:ext cx="0" cy="0"/>
+          <a:chOff x="0" y="0"/>
+          <a:chExt cx="0" cy="0"/>
+        </a:xfrm>
+      </p:grpSpPr>
+      <p:sp>
+        <p:nvSpPr>
+          <p:cNvPr id="3" name="TextBox 2">
+            <a:extLst>
+              <a:ext uri="{FF2B5EF4-FFF2-40B4-BE49-F238E27FC236}">
+                <a16:creationId xmlns:a16="http://schemas.microsoft.com/office/drawing/2014/main" id="{89A2ACF6-29CD-16DC-632F-49937A2B6613}"/>
+              </a:ext>
+            </a:extLst>
+          </p:cNvPr>
+          <p:cNvSpPr txBox="1"/>
+          <p:nvPr/>
+        </p:nvSpPr>
+        <p:spPr>
+          <a:xfrm>
+            <a:off x="217714" y="73175"/>
+            <a:ext cx="11756571" cy="355354"/>
+          </a:xfrm>
+          <a:prstGeom prst="rect">
+            <a:avLst/>
+          </a:prstGeom>
+          <a:noFill/>
+        </p:spPr>
+        <p:txBody>
+          <a:bodyPr wrap="square">
+            <a:spAutoFit/>
+          </a:bodyPr>
+          <a:lstStyle/>
+          <a:p>
+            <a:pPr>
+              <a:lnSpc>
+                <a:spcPct val="150000"/>
+              </a:lnSpc>
+              <a:buNone/>
+            </a:pPr>
+            <a:r>
+              <a:rPr lang="az-Latn-AZ" altLang="en-US" sz="1300" b="1">
+                <a:latin typeface="Arial" panose="020B0604020202020204" pitchFamily="34" charset="0"/>
+              </a:rPr>
+              <a:t>Slider</a:t>
+            </a:r>
+            <a:r>
+              <a:rPr lang="az-Latn-AZ" altLang="en-US" sz="1300">
+                <a:latin typeface="Arial" panose="020B0604020202020204" pitchFamily="34" charset="0"/>
+              </a:rPr>
+              <a:t> modelindən seçilən dataları, </a:t>
+            </a:r>
+            <a:r>
+              <a:rPr lang="az-Latn-AZ" altLang="en-US" sz="1300" b="1">
+                <a:latin typeface="Arial" panose="020B0604020202020204" pitchFamily="34" charset="0"/>
+              </a:rPr>
+              <a:t>edit.blade.php </a:t>
+            </a:r>
+            <a:r>
+              <a:rPr lang="az-Latn-AZ" altLang="en-US" sz="1300">
+                <a:latin typeface="Arial" panose="020B0604020202020204" pitchFamily="34" charset="0"/>
+              </a:rPr>
+              <a:t>faylına göndəririk.             4cü slaydda, isə düyməni kliklədikdə həmin dataları </a:t>
+            </a:r>
+            <a:r>
+              <a:rPr lang="az-Latn-AZ" altLang="en-US" sz="1300" b="1">
+                <a:latin typeface="Arial" panose="020B0604020202020204" pitchFamily="34" charset="0"/>
+              </a:rPr>
+              <a:t>UPDATE</a:t>
+            </a:r>
+            <a:r>
+              <a:rPr lang="az-Latn-AZ" altLang="en-US" sz="1300">
+                <a:latin typeface="Arial" panose="020B0604020202020204" pitchFamily="34" charset="0"/>
+              </a:rPr>
+              <a:t> edəcəyik. </a:t>
+            </a:r>
+            <a:endParaRPr kumimoji="0" lang="en-US" altLang="en-US" sz="1300" b="0" i="0" u="none" strike="noStrike" cap="none" normalizeH="0" baseline="0">
+              <a:ln>
+                <a:noFill/>
+              </a:ln>
+              <a:solidFill>
+                <a:schemeClr val="tx1"/>
+              </a:solidFill>
+              <a:effectLst/>
+              <a:latin typeface="Arial" panose="020B0604020202020204" pitchFamily="34" charset="0"/>
+            </a:endParaRPr>
+          </a:p>
+        </p:txBody>
+      </p:sp>
+      <p:pic>
+        <p:nvPicPr>
+          <p:cNvPr id="4" name="Picture 3">
+            <a:extLst>
+              <a:ext uri="{FF2B5EF4-FFF2-40B4-BE49-F238E27FC236}">
+                <a16:creationId xmlns:a16="http://schemas.microsoft.com/office/drawing/2014/main" id="{CA2BFD38-C762-0AA6-0C35-89E1EFA3ED2D}"/>
+              </a:ext>
+            </a:extLst>
+          </p:cNvPr>
+          <p:cNvPicPr>
+            <a:picLocks noChangeAspect="1"/>
+          </p:cNvPicPr>
+          <p:nvPr/>
+        </p:nvPicPr>
+        <p:blipFill>
+          <a:blip r:embed="rId2"/>
+          <a:stretch>
+            <a:fillRect/>
+          </a:stretch>
+        </p:blipFill>
+        <p:spPr>
+          <a:xfrm>
+            <a:off x="0" y="511657"/>
+            <a:ext cx="12192000" cy="6346343"/>
+          </a:xfrm>
+          <a:prstGeom prst="rect">
+            <a:avLst/>
+          </a:prstGeom>
+        </p:spPr>
+      </p:pic>
+    </p:spTree>
+    <p:extLst>
+      <p:ext uri="{BB962C8B-B14F-4D97-AF65-F5344CB8AC3E}">
+        <p14:creationId xmlns:p14="http://schemas.microsoft.com/office/powerpoint/2010/main" val="239628937"/>
+      </p:ext>
+    </p:extLst>
+  </p:cSld>
+  <p:clrMapOvr>
+    <a:masterClrMapping/>
+  </p:clrMapOvr>
+</p:sld>
+</file>
+
+<file path=ppt/slides/slide3.xml><?xml version="1.0" encoding="utf-8"?>
+<p:sld xmlns:a="http://schemas.openxmlformats.org/drawingml/2006/main" xmlns:r="http://schemas.openxmlformats.org/officeDocument/2006/relationships" xmlns:p="http://schemas.openxmlformats.org/presentationml/2006/main">
+  <p:cSld>
+    <p:spTree>
+      <p:nvGrpSpPr>
+        <p:cNvPr id="1" name="">
+          <a:extLst>
+            <a:ext uri="{FF2B5EF4-FFF2-40B4-BE49-F238E27FC236}">
+              <a16:creationId xmlns:a16="http://schemas.microsoft.com/office/drawing/2014/main" id="{5C376563-DE4F-90F7-71BD-3A5F9C04B872}"/>
+            </a:ext>
+          </a:extLst>
+        </p:cNvPr>
+        <p:cNvGrpSpPr/>
+        <p:nvPr/>
+      </p:nvGrpSpPr>
+      <p:grpSpPr>
+        <a:xfrm>
+          <a:off x="0" y="0"/>
+          <a:ext cx="0" cy="0"/>
+          <a:chOff x="0" y="0"/>
+          <a:chExt cx="0" cy="0"/>
+        </a:xfrm>
+      </p:grpSpPr>
+      <p:sp>
+        <p:nvSpPr>
+          <p:cNvPr id="3" name="TextBox 2">
+            <a:extLst>
+              <a:ext uri="{FF2B5EF4-FFF2-40B4-BE49-F238E27FC236}">
+                <a16:creationId xmlns:a16="http://schemas.microsoft.com/office/drawing/2014/main" id="{6ECE13F1-1BBE-37A8-1C45-955FCE10F74A}"/>
+              </a:ext>
+            </a:extLst>
+          </p:cNvPr>
+          <p:cNvSpPr txBox="1"/>
+          <p:nvPr/>
+        </p:nvSpPr>
+        <p:spPr>
+          <a:xfrm>
+            <a:off x="217714" y="255046"/>
+            <a:ext cx="11756571" cy="355354"/>
+          </a:xfrm>
+          <a:prstGeom prst="rect">
+            <a:avLst/>
+          </a:prstGeom>
+          <a:noFill/>
+        </p:spPr>
+        <p:txBody>
+          <a:bodyPr wrap="square">
+            <a:spAutoFit/>
+          </a:bodyPr>
+          <a:lstStyle/>
+          <a:p>
+            <a:pPr>
+              <a:lnSpc>
+                <a:spcPct val="150000"/>
+              </a:lnSpc>
+              <a:buNone/>
+            </a:pPr>
+            <a:r>
+              <a:rPr lang="az-Latn-AZ" altLang="en-US" sz="1300" b="1">
+                <a:latin typeface="Arial" panose="020B0604020202020204" pitchFamily="34" charset="0"/>
+              </a:rPr>
+              <a:t>2ci </a:t>
+            </a:r>
+            <a:r>
+              <a:rPr lang="az-Latn-AZ" altLang="en-US" sz="1300">
+                <a:latin typeface="Arial" panose="020B0604020202020204" pitchFamily="34" charset="0"/>
+              </a:rPr>
+              <a:t>slayddakı </a:t>
+            </a:r>
+            <a:r>
+              <a:rPr lang="az-Latn-AZ" altLang="en-US" sz="1300" b="1">
+                <a:latin typeface="Arial" panose="020B0604020202020204" pitchFamily="34" charset="0"/>
+              </a:rPr>
+              <a:t>FORM</a:t>
+            </a:r>
+            <a:r>
+              <a:rPr lang="az-Latn-AZ" altLang="en-US" sz="1300">
+                <a:latin typeface="Arial" panose="020B0604020202020204" pitchFamily="34" charset="0"/>
+              </a:rPr>
+              <a:t> elementinə əlavə edilən </a:t>
+            </a:r>
+            <a:r>
+              <a:rPr lang="az-Latn-AZ" altLang="en-US" sz="1300" b="1">
+                <a:latin typeface="Arial" panose="020B0604020202020204" pitchFamily="34" charset="0"/>
+              </a:rPr>
+              <a:t>route</a:t>
+            </a:r>
+            <a:r>
+              <a:rPr lang="az-Latn-AZ" altLang="en-US" sz="1300">
+                <a:latin typeface="Arial" panose="020B0604020202020204" pitchFamily="34" charset="0"/>
+              </a:rPr>
+              <a:t>, dataları </a:t>
+            </a:r>
+            <a:r>
+              <a:rPr lang="az-Latn-AZ" altLang="en-US" sz="1300" b="1">
+                <a:latin typeface="Arial" panose="020B0604020202020204" pitchFamily="34" charset="0"/>
+              </a:rPr>
+              <a:t>UPDATE</a:t>
+            </a:r>
+            <a:r>
+              <a:rPr lang="az-Latn-AZ" altLang="en-US" sz="1300">
+                <a:latin typeface="Arial" panose="020B0604020202020204" pitchFamily="34" charset="0"/>
+              </a:rPr>
+              <a:t> etmək üçündür. </a:t>
+            </a:r>
+            <a:endParaRPr kumimoji="0" lang="en-US" altLang="en-US" sz="1300" b="0" i="0" u="none" strike="noStrike" cap="none" normalizeH="0" baseline="0">
+              <a:ln>
+                <a:noFill/>
+              </a:ln>
+              <a:solidFill>
+                <a:schemeClr val="tx1"/>
+              </a:solidFill>
+              <a:effectLst/>
+              <a:latin typeface="Arial" panose="020B0604020202020204" pitchFamily="34" charset="0"/>
+            </a:endParaRPr>
+          </a:p>
+        </p:txBody>
+      </p:sp>
+      <p:pic>
+        <p:nvPicPr>
+          <p:cNvPr id="4" name="Picture 3">
+            <a:extLst>
+              <a:ext uri="{FF2B5EF4-FFF2-40B4-BE49-F238E27FC236}">
+                <a16:creationId xmlns:a16="http://schemas.microsoft.com/office/drawing/2014/main" id="{3BA2EAA1-8884-9C30-193E-864E3B6BAEF6}"/>
+              </a:ext>
+            </a:extLst>
+          </p:cNvPr>
+          <p:cNvPicPr>
+            <a:picLocks noChangeAspect="1"/>
+          </p:cNvPicPr>
+          <p:nvPr/>
+        </p:nvPicPr>
+        <p:blipFill>
+          <a:blip r:embed="rId2"/>
+          <a:stretch>
+            <a:fillRect/>
+          </a:stretch>
+        </p:blipFill>
+        <p:spPr>
+          <a:xfrm>
+            <a:off x="-1" y="797649"/>
+            <a:ext cx="12192000" cy="6060351"/>
+          </a:xfrm>
+          <a:prstGeom prst="rect">
+            <a:avLst/>
+          </a:prstGeom>
+        </p:spPr>
+      </p:pic>
+    </p:spTree>
+    <p:extLst>
+      <p:ext uri="{BB962C8B-B14F-4D97-AF65-F5344CB8AC3E}">
+        <p14:creationId xmlns:p14="http://schemas.microsoft.com/office/powerpoint/2010/main" val="4111497821"/>
+      </p:ext>
+    </p:extLst>
+  </p:cSld>
+  <p:clrMapOvr>
+    <a:masterClrMapping/>
+  </p:clrMapOvr>
+</p:sld>
+</file>
+
+<file path=ppt/slides/slide4.xml><?xml version="1.0" encoding="utf-8"?>
+<p:sld xmlns:a="http://schemas.openxmlformats.org/drawingml/2006/main" xmlns:r="http://schemas.openxmlformats.org/officeDocument/2006/relationships" xmlns:p="http://schemas.openxmlformats.org/presentationml/2006/main">
+  <p:cSld>
+    <p:spTree>
+      <p:nvGrpSpPr>
+        <p:cNvPr id="1" name="">
+          <a:extLst>
+            <a:ext uri="{FF2B5EF4-FFF2-40B4-BE49-F238E27FC236}">
+              <a16:creationId xmlns:a16="http://schemas.microsoft.com/office/drawing/2014/main" id="{EE2F9221-3354-E526-9C7A-46B1EB2A9001}"/>
+            </a:ext>
+          </a:extLst>
+        </p:cNvPr>
+        <p:cNvGrpSpPr/>
+        <p:nvPr/>
+      </p:nvGrpSpPr>
+      <p:grpSpPr>
+        <a:xfrm>
+          <a:off x="0" y="0"/>
+          <a:ext cx="0" cy="0"/>
+          <a:chOff x="0" y="0"/>
+          <a:chExt cx="0" cy="0"/>
+        </a:xfrm>
+      </p:grpSpPr>
+      <p:sp>
+        <p:nvSpPr>
+          <p:cNvPr id="3" name="TextBox 2">
+            <a:extLst>
+              <a:ext uri="{FF2B5EF4-FFF2-40B4-BE49-F238E27FC236}">
+                <a16:creationId xmlns:a16="http://schemas.microsoft.com/office/drawing/2014/main" id="{814DFC35-3F85-898B-4980-517880A9A77B}"/>
+              </a:ext>
+            </a:extLst>
+          </p:cNvPr>
+          <p:cNvSpPr txBox="1"/>
+          <p:nvPr/>
+        </p:nvSpPr>
+        <p:spPr>
+          <a:xfrm>
+            <a:off x="217714" y="255046"/>
+            <a:ext cx="11756571" cy="355354"/>
+          </a:xfrm>
+          <a:prstGeom prst="rect">
+            <a:avLst/>
+          </a:prstGeom>
+          <a:noFill/>
+        </p:spPr>
+        <p:txBody>
+          <a:bodyPr wrap="square">
+            <a:spAutoFit/>
+          </a:bodyPr>
+          <a:lstStyle/>
+          <a:p>
+            <a:pPr>
+              <a:lnSpc>
+                <a:spcPct val="150000"/>
+              </a:lnSpc>
+              <a:buNone/>
+            </a:pPr>
+            <a:r>
+              <a:rPr lang="az-Latn-AZ" altLang="en-US" sz="1300">
+                <a:latin typeface="Arial" panose="020B0604020202020204" pitchFamily="34" charset="0"/>
+              </a:rPr>
+              <a:t>Hələki </a:t>
+            </a:r>
+            <a:r>
+              <a:rPr lang="az-Latn-AZ" altLang="en-US" sz="1300" b="1">
+                <a:latin typeface="Arial" panose="020B0604020202020204" pitchFamily="34" charset="0"/>
+              </a:rPr>
+              <a:t>UPDATE</a:t>
+            </a:r>
+            <a:r>
+              <a:rPr lang="az-Latn-AZ" altLang="en-US" sz="1300">
+                <a:latin typeface="Arial" panose="020B0604020202020204" pitchFamily="34" charset="0"/>
+              </a:rPr>
+              <a:t> etməmişik və nəticə bu cürdür. </a:t>
+            </a:r>
+            <a:endParaRPr kumimoji="0" lang="en-US" altLang="en-US" sz="1300" b="0" i="0" u="none" strike="noStrike" cap="none" normalizeH="0" baseline="0">
+              <a:ln>
+                <a:noFill/>
+              </a:ln>
+              <a:solidFill>
+                <a:schemeClr val="tx1"/>
+              </a:solidFill>
+              <a:effectLst/>
+              <a:latin typeface="Arial" panose="020B0604020202020204" pitchFamily="34" charset="0"/>
+            </a:endParaRPr>
+          </a:p>
+        </p:txBody>
+      </p:sp>
+      <p:pic>
+        <p:nvPicPr>
+          <p:cNvPr id="4" name="Picture 3">
+            <a:extLst>
+              <a:ext uri="{FF2B5EF4-FFF2-40B4-BE49-F238E27FC236}">
+                <a16:creationId xmlns:a16="http://schemas.microsoft.com/office/drawing/2014/main" id="{388435B1-69BA-55AA-DF90-6A1B2B57DBB7}"/>
+              </a:ext>
+            </a:extLst>
+          </p:cNvPr>
+          <p:cNvPicPr>
+            <a:picLocks noChangeAspect="1"/>
+          </p:cNvPicPr>
+          <p:nvPr/>
+        </p:nvPicPr>
+        <p:blipFill>
+          <a:blip r:embed="rId2"/>
+          <a:stretch>
+            <a:fillRect/>
+          </a:stretch>
+        </p:blipFill>
+        <p:spPr>
+          <a:xfrm>
+            <a:off x="0" y="720704"/>
+            <a:ext cx="12192000" cy="6137296"/>
+          </a:xfrm>
+          <a:prstGeom prst="rect">
+            <a:avLst/>
+          </a:prstGeom>
+          <a:ln w="38100" cap="sq">
+            <a:solidFill>
+              <a:srgbClr val="000000"/>
+            </a:solidFill>
+            <a:prstDash val="solid"/>
+            <a:miter lim="800000"/>
+          </a:ln>
+          <a:effectLst>
+            <a:outerShdw blurRad="50800" dist="38100" dir="2700000" algn="tl" rotWithShape="0">
+              <a:srgbClr val="000000">
+                <a:alpha val="43000"/>
+              </a:srgbClr>
+            </a:outerShdw>
+          </a:effectLst>
+        </p:spPr>
+      </p:pic>
+    </p:spTree>
+    <p:extLst>
+      <p:ext uri="{BB962C8B-B14F-4D97-AF65-F5344CB8AC3E}">
+        <p14:creationId xmlns:p14="http://schemas.microsoft.com/office/powerpoint/2010/main" val="4183653381"/>
+      </p:ext>
+    </p:extLst>
+  </p:cSld>
+  <p:clrMapOvr>
+    <a:masterClrMapping/>
+  </p:clrMapOvr>
+</p:sld>
+</file>
+
+<file path=ppt/slides/slide5.xml><?xml version="1.0" encoding="utf-8"?>
 <p:sld xmlns:a="http://schemas.openxmlformats.org/drawingml/2006/main" xmlns:r="http://schemas.openxmlformats.org/officeDocument/2006/relationships" xmlns:p="http://schemas.openxmlformats.org/presentationml/2006/main">
   <p:cSld>
     <p:spTree>
@@ -3435,7 +4220,7 @@
         <p:spPr>
           <a:xfrm>
             <a:off x="217714" y="255046"/>
-            <a:ext cx="11756571" cy="355354"/>
+            <a:ext cx="11756571" cy="1555682"/>
           </a:xfrm>
           <a:prstGeom prst="rect">
             <a:avLst/>
@@ -3455,21 +4240,241 @@
               <a:buNone/>
             </a:pPr>
             <a:r>
-              <a:rPr kumimoji="0" lang="en-US" altLang="en-US" sz="1300" b="0" i="0" u="none" strike="noStrike" cap="none" normalizeH="0" baseline="0">
-                <a:ln>
-                  <a:noFill/>
-                </a:ln>
-                <a:solidFill>
-                  <a:schemeClr val="tx1"/>
-                </a:solidFill>
-                <a:effectLst/>
-                <a:latin typeface="Arial" panose="020B0604020202020204" pitchFamily="34" charset="0"/>
-              </a:rPr>
-              <a:t>.</a:t>
-            </a:r>
-          </a:p>
-        </p:txBody>
-      </p:sp>
+              <a:rPr lang="az-Latn-AZ" altLang="en-US" sz="1300">
+                <a:latin typeface="Arial" panose="020B0604020202020204" pitchFamily="34" charset="0"/>
+              </a:rPr>
+              <a:t>Dataları </a:t>
+            </a:r>
+            <a:r>
+              <a:rPr lang="az-Latn-AZ" altLang="en-US" sz="1300" b="1">
+                <a:latin typeface="Arial" panose="020B0604020202020204" pitchFamily="34" charset="0"/>
+              </a:rPr>
+              <a:t>update</a:t>
+            </a:r>
+            <a:r>
+              <a:rPr lang="az-Latn-AZ" altLang="en-US" sz="1300">
+                <a:latin typeface="Arial" panose="020B0604020202020204" pitchFamily="34" charset="0"/>
+              </a:rPr>
+              <a:t> etmək üçün</a:t>
+            </a:r>
+            <a:r>
+              <a:rPr lang="en-US" altLang="en-US" sz="1300">
+                <a:latin typeface="Arial" panose="020B0604020202020204" pitchFamily="34" charset="0"/>
+              </a:rPr>
+              <a:t> `</a:t>
+            </a:r>
+            <a:r>
+              <a:rPr lang="en-US" altLang="en-US" sz="1300" b="1">
+                <a:latin typeface="Arial" panose="020B0604020202020204" pitchFamily="34" charset="0"/>
+              </a:rPr>
+              <a:t>app\Http\Controllers\Backend\</a:t>
+            </a:r>
+            <a:r>
+              <a:rPr lang="en-US" altLang="en-US" sz="1300" b="1" u="sng">
+                <a:latin typeface="Arial" panose="020B0604020202020204" pitchFamily="34" charset="0"/>
+              </a:rPr>
+              <a:t>SliderController.php</a:t>
+            </a:r>
+            <a:r>
+              <a:rPr lang="en-US" altLang="en-US" sz="1300">
+                <a:latin typeface="Arial" panose="020B0604020202020204" pitchFamily="34" charset="0"/>
+              </a:rPr>
+              <a:t>` kontrollerind</a:t>
+            </a:r>
+            <a:r>
+              <a:rPr lang="az-Latn-AZ" altLang="en-US" sz="1300">
+                <a:latin typeface="Arial" panose="020B0604020202020204" pitchFamily="34" charset="0"/>
+              </a:rPr>
+              <a:t>əki, </a:t>
+            </a:r>
+            <a:r>
+              <a:rPr lang="az-Latn-AZ" altLang="en-US" sz="1300" b="1">
+                <a:latin typeface="Arial" panose="020B0604020202020204" pitchFamily="34" charset="0"/>
+              </a:rPr>
+              <a:t>public function </a:t>
+            </a:r>
+            <a:r>
+              <a:rPr lang="en-US" altLang="en-US" sz="1300" b="1">
+                <a:latin typeface="Arial" panose="020B0604020202020204" pitchFamily="34" charset="0"/>
+              </a:rPr>
+              <a:t>update</a:t>
+            </a:r>
+            <a:r>
+              <a:rPr lang="az-Latn-AZ" altLang="en-US" sz="1300" b="1">
+                <a:latin typeface="Arial" panose="020B0604020202020204" pitchFamily="34" charset="0"/>
+              </a:rPr>
+              <a:t>(Request $request) </a:t>
+            </a:r>
+            <a:r>
+              <a:rPr lang="en-US" altLang="en-US" sz="1300" b="1">
+                <a:latin typeface="Arial" panose="020B0604020202020204" pitchFamily="34" charset="0"/>
+              </a:rPr>
+              <a:t>{ } </a:t>
+            </a:r>
+            <a:r>
+              <a:rPr lang="az-Latn-AZ" altLang="en-US" sz="1300">
+                <a:latin typeface="Arial" panose="020B0604020202020204" pitchFamily="34" charset="0"/>
+              </a:rPr>
+              <a:t>funksiyasından istifadə edəcəyik.</a:t>
+            </a:r>
+            <a:endParaRPr lang="en-US" altLang="en-US" sz="1300">
+              <a:latin typeface="Arial" panose="020B0604020202020204" pitchFamily="34" charset="0"/>
+            </a:endParaRPr>
+          </a:p>
+          <a:p>
+            <a:pPr>
+              <a:lnSpc>
+                <a:spcPct val="150000"/>
+              </a:lnSpc>
+              <a:buNone/>
+            </a:pPr>
+            <a:endParaRPr kumimoji="0" lang="en-US" altLang="en-US" sz="1300" b="0" i="0" u="none" strike="noStrike" cap="none" normalizeH="0" baseline="0">
+              <a:ln>
+                <a:noFill/>
+              </a:ln>
+              <a:solidFill>
+                <a:schemeClr val="tx1"/>
+              </a:solidFill>
+              <a:effectLst/>
+              <a:latin typeface="Arial" panose="020B0604020202020204" pitchFamily="34" charset="0"/>
+            </a:endParaRPr>
+          </a:p>
+          <a:p>
+            <a:pPr marL="342900" indent="-342900">
+              <a:lnSpc>
+                <a:spcPct val="150000"/>
+              </a:lnSpc>
+              <a:buAutoNum type="arabicParenR"/>
+            </a:pPr>
+            <a:r>
+              <a:rPr lang="en-US" altLang="en-US" sz="1300" b="1">
+                <a:latin typeface="Arial" panose="020B0604020202020204" pitchFamily="34" charset="0"/>
+              </a:rPr>
+              <a:t>app\Traits\ImageUploadTrait.php </a:t>
+            </a:r>
+            <a:r>
+              <a:rPr lang="az-Latn-AZ" altLang="en-US" sz="1300">
+                <a:latin typeface="Arial" panose="020B0604020202020204" pitchFamily="34" charset="0"/>
+              </a:rPr>
+              <a:t>adlı </a:t>
+            </a:r>
+            <a:r>
+              <a:rPr lang="az-Latn-AZ" altLang="en-US" sz="1300" b="1">
+                <a:latin typeface="Arial" panose="020B0604020202020204" pitchFamily="34" charset="0"/>
+              </a:rPr>
+              <a:t>trait</a:t>
+            </a:r>
+            <a:r>
+              <a:rPr lang="az-Latn-AZ" altLang="en-US" sz="1300">
+                <a:latin typeface="Arial" panose="020B0604020202020204" pitchFamily="34" charset="0"/>
+              </a:rPr>
+              <a:t> içində şəklin olub olmadığını kontrol edən funkisyasımızı yazırıq.</a:t>
+            </a:r>
+          </a:p>
+          <a:p>
+            <a:pPr marL="342900" indent="-342900">
+              <a:lnSpc>
+                <a:spcPct val="150000"/>
+              </a:lnSpc>
+              <a:buAutoNum type="arabicParenR"/>
+            </a:pPr>
+            <a:r>
+              <a:rPr lang="en-US" altLang="en-US" sz="1300" b="1">
+                <a:latin typeface="Arial" panose="020B0604020202020204" pitchFamily="34" charset="0"/>
+              </a:rPr>
+              <a:t>app\Http\Controllers\Backend\SliderController.php</a:t>
+            </a:r>
+            <a:r>
+              <a:rPr lang="az-Latn-AZ" altLang="en-US" sz="1300" b="1">
+                <a:latin typeface="Arial" panose="020B0604020202020204" pitchFamily="34" charset="0"/>
+              </a:rPr>
+              <a:t> </a:t>
+            </a:r>
+            <a:r>
+              <a:rPr lang="az-Latn-AZ" altLang="en-US" sz="1300">
+                <a:latin typeface="Arial" panose="020B0604020202020204" pitchFamily="34" charset="0"/>
+              </a:rPr>
+              <a:t>kontrollerində isə </a:t>
+            </a:r>
+            <a:r>
+              <a:rPr lang="az-Latn-AZ" altLang="en-US" sz="1300" b="1">
+                <a:latin typeface="Arial" panose="020B0604020202020204" pitchFamily="34" charset="0"/>
+              </a:rPr>
+              <a:t>updateImage() </a:t>
+            </a:r>
+            <a:r>
+              <a:rPr lang="az-Latn-AZ" altLang="en-US" sz="1300">
+                <a:latin typeface="Arial" panose="020B0604020202020204" pitchFamily="34" charset="0"/>
+              </a:rPr>
+              <a:t>metodunun </a:t>
+            </a:r>
+            <a:r>
+              <a:rPr lang="az-Latn-AZ" altLang="en-US" sz="1300" b="1">
+                <a:latin typeface="Arial" panose="020B0604020202020204" pitchFamily="34" charset="0"/>
+              </a:rPr>
+              <a:t>return</a:t>
+            </a:r>
+            <a:r>
+              <a:rPr lang="az-Latn-AZ" altLang="en-US" sz="1300">
+                <a:latin typeface="Arial" panose="020B0604020202020204" pitchFamily="34" charset="0"/>
+              </a:rPr>
+              <a:t> etdiyi dəyəri əldə edərək </a:t>
+            </a:r>
+            <a:r>
+              <a:rPr lang="az-Latn-AZ" altLang="en-US" sz="1300" b="1">
+                <a:latin typeface="Arial" panose="020B0604020202020204" pitchFamily="34" charset="0"/>
+              </a:rPr>
+              <a:t>DB</a:t>
+            </a:r>
+            <a:r>
+              <a:rPr lang="az-Latn-AZ" altLang="en-US" sz="1300">
+                <a:latin typeface="Arial" panose="020B0604020202020204" pitchFamily="34" charset="0"/>
+              </a:rPr>
+              <a:t> -si yeniləyirik.</a:t>
+            </a:r>
+            <a:endParaRPr kumimoji="0" lang="en-US" altLang="en-US" sz="1300" b="0" i="0" u="none" strike="noStrike" cap="none" normalizeH="0" baseline="0">
+              <a:ln>
+                <a:noFill/>
+              </a:ln>
+              <a:solidFill>
+                <a:schemeClr val="tx1"/>
+              </a:solidFill>
+              <a:effectLst/>
+              <a:latin typeface="Arial" panose="020B0604020202020204" pitchFamily="34" charset="0"/>
+            </a:endParaRPr>
+          </a:p>
+        </p:txBody>
+      </p:sp>
+      <p:pic>
+        <p:nvPicPr>
+          <p:cNvPr id="4" name="Picture 3">
+            <a:extLst>
+              <a:ext uri="{FF2B5EF4-FFF2-40B4-BE49-F238E27FC236}">
+                <a16:creationId xmlns:a16="http://schemas.microsoft.com/office/drawing/2014/main" id="{268D1376-0AEE-9C82-1FE9-5B421974EF28}"/>
+              </a:ext>
+            </a:extLst>
+          </p:cNvPr>
+          <p:cNvPicPr>
+            <a:picLocks noChangeAspect="1"/>
+          </p:cNvPicPr>
+          <p:nvPr/>
+        </p:nvPicPr>
+        <p:blipFill>
+          <a:blip r:embed="rId2"/>
+          <a:stretch>
+            <a:fillRect/>
+          </a:stretch>
+        </p:blipFill>
+        <p:spPr>
+          <a:xfrm>
+            <a:off x="4077570" y="2327564"/>
+            <a:ext cx="8114429" cy="4530436"/>
+          </a:xfrm>
+          <a:prstGeom prst="rect">
+            <a:avLst/>
+          </a:prstGeom>
+        </p:spPr>
+      </p:pic>
     </p:spTree>
     <p:extLst>
       <p:ext uri="{BB962C8B-B14F-4D97-AF65-F5344CB8AC3E}">
@@ -3483,7 +4488,265 @@
 </p:sld>
 </file>
 
-<file path=ppt/slides/slide3.xml><?xml version="1.0" encoding="utf-8"?>
+<file path=ppt/slides/slide6.xml><?xml version="1.0" encoding="utf-8"?>
+<p:sld xmlns:a="http://schemas.openxmlformats.org/drawingml/2006/main" xmlns:r="http://schemas.openxmlformats.org/officeDocument/2006/relationships" xmlns:p="http://schemas.openxmlformats.org/presentationml/2006/main">
+  <p:cSld>
+    <p:spTree>
+      <p:nvGrpSpPr>
+        <p:cNvPr id="1" name="">
+          <a:extLst>
+            <a:ext uri="{FF2B5EF4-FFF2-40B4-BE49-F238E27FC236}">
+              <a16:creationId xmlns:a16="http://schemas.microsoft.com/office/drawing/2014/main" id="{A0FE652A-827F-5D2E-C88F-3C3E3A1BE9EE}"/>
+            </a:ext>
+          </a:extLst>
+        </p:cNvPr>
+        <p:cNvGrpSpPr/>
+        <p:nvPr/>
+      </p:nvGrpSpPr>
+      <p:grpSpPr>
+        <a:xfrm>
+          <a:off x="0" y="0"/>
+          <a:ext cx="0" cy="0"/>
+          <a:chOff x="0" y="0"/>
+          <a:chExt cx="0" cy="0"/>
+        </a:xfrm>
+      </p:grpSpPr>
+      <p:sp>
+        <p:nvSpPr>
+          <p:cNvPr id="3" name="TextBox 2">
+            <a:extLst>
+              <a:ext uri="{FF2B5EF4-FFF2-40B4-BE49-F238E27FC236}">
+                <a16:creationId xmlns:a16="http://schemas.microsoft.com/office/drawing/2014/main" id="{D97FC9DD-A4ED-BE9B-B409-C84B811D5F5E}"/>
+              </a:ext>
+            </a:extLst>
+          </p:cNvPr>
+          <p:cNvSpPr txBox="1"/>
+          <p:nvPr/>
+        </p:nvSpPr>
+        <p:spPr>
+          <a:xfrm>
+            <a:off x="217714" y="255046"/>
+            <a:ext cx="11756571" cy="355354"/>
+          </a:xfrm>
+          <a:prstGeom prst="rect">
+            <a:avLst/>
+          </a:prstGeom>
+          <a:noFill/>
+        </p:spPr>
+        <p:txBody>
+          <a:bodyPr wrap="square">
+            <a:spAutoFit/>
+          </a:bodyPr>
+          <a:lstStyle/>
+          <a:p>
+            <a:pPr>
+              <a:lnSpc>
+                <a:spcPct val="150000"/>
+              </a:lnSpc>
+              <a:buNone/>
+            </a:pPr>
+            <a:r>
+              <a:rPr kumimoji="0" lang="en-US" altLang="en-US" sz="1300" b="0" i="0" u="none" strike="noStrike" cap="none" normalizeH="0" baseline="0">
+                <a:ln>
+                  <a:noFill/>
+                </a:ln>
+                <a:solidFill>
+                  <a:schemeClr val="tx1"/>
+                </a:solidFill>
+                <a:effectLst/>
+                <a:latin typeface="Arial" panose="020B0604020202020204" pitchFamily="34" charset="0"/>
+              </a:rPr>
+              <a:t>.</a:t>
+            </a:r>
+          </a:p>
+        </p:txBody>
+      </p:sp>
+    </p:spTree>
+    <p:extLst>
+      <p:ext uri="{BB962C8B-B14F-4D97-AF65-F5344CB8AC3E}">
+        <p14:creationId xmlns:p14="http://schemas.microsoft.com/office/powerpoint/2010/main" val="3056364976"/>
+      </p:ext>
+    </p:extLst>
+  </p:cSld>
+  <p:clrMapOvr>
+    <a:masterClrMapping/>
+  </p:clrMapOvr>
+</p:sld>
+</file>
+
+<file path=ppt/slides/slide7.xml><?xml version="1.0" encoding="utf-8"?>
+<p:sld xmlns:a="http://schemas.openxmlformats.org/drawingml/2006/main" xmlns:r="http://schemas.openxmlformats.org/officeDocument/2006/relationships" xmlns:p="http://schemas.openxmlformats.org/presentationml/2006/main">
+  <p:cSld>
+    <p:spTree>
+      <p:nvGrpSpPr>
+        <p:cNvPr id="1" name="">
+          <a:extLst>
+            <a:ext uri="{FF2B5EF4-FFF2-40B4-BE49-F238E27FC236}">
+              <a16:creationId xmlns:a16="http://schemas.microsoft.com/office/drawing/2014/main" id="{8BBDB016-6A0E-D004-C6A6-0F4DB556C863}"/>
+            </a:ext>
+          </a:extLst>
+        </p:cNvPr>
+        <p:cNvGrpSpPr/>
+        <p:nvPr/>
+      </p:nvGrpSpPr>
+      <p:grpSpPr>
+        <a:xfrm>
+          <a:off x="0" y="0"/>
+          <a:ext cx="0" cy="0"/>
+          <a:chOff x="0" y="0"/>
+          <a:chExt cx="0" cy="0"/>
+        </a:xfrm>
+      </p:grpSpPr>
+      <p:sp>
+        <p:nvSpPr>
+          <p:cNvPr id="3" name="TextBox 2">
+            <a:extLst>
+              <a:ext uri="{FF2B5EF4-FFF2-40B4-BE49-F238E27FC236}">
+                <a16:creationId xmlns:a16="http://schemas.microsoft.com/office/drawing/2014/main" id="{40AA2811-0F40-94A6-DADE-EC75B479A710}"/>
+              </a:ext>
+            </a:extLst>
+          </p:cNvPr>
+          <p:cNvSpPr txBox="1"/>
+          <p:nvPr/>
+        </p:nvSpPr>
+        <p:spPr>
+          <a:xfrm>
+            <a:off x="217714" y="255046"/>
+            <a:ext cx="11756571" cy="355354"/>
+          </a:xfrm>
+          <a:prstGeom prst="rect">
+            <a:avLst/>
+          </a:prstGeom>
+          <a:noFill/>
+        </p:spPr>
+        <p:txBody>
+          <a:bodyPr wrap="square">
+            <a:spAutoFit/>
+          </a:bodyPr>
+          <a:lstStyle/>
+          <a:p>
+            <a:pPr>
+              <a:lnSpc>
+                <a:spcPct val="150000"/>
+              </a:lnSpc>
+              <a:buNone/>
+            </a:pPr>
+            <a:r>
+              <a:rPr kumimoji="0" lang="en-US" altLang="en-US" sz="1300" b="0" i="0" u="none" strike="noStrike" cap="none" normalizeH="0" baseline="0">
+                <a:ln>
+                  <a:noFill/>
+                </a:ln>
+                <a:solidFill>
+                  <a:schemeClr val="tx1"/>
+                </a:solidFill>
+                <a:effectLst/>
+                <a:latin typeface="Arial" panose="020B0604020202020204" pitchFamily="34" charset="0"/>
+              </a:rPr>
+              <a:t>.</a:t>
+            </a:r>
+          </a:p>
+        </p:txBody>
+      </p:sp>
+    </p:spTree>
+    <p:extLst>
+      <p:ext uri="{BB962C8B-B14F-4D97-AF65-F5344CB8AC3E}">
+        <p14:creationId xmlns:p14="http://schemas.microsoft.com/office/powerpoint/2010/main" val="643375418"/>
+      </p:ext>
+    </p:extLst>
+  </p:cSld>
+  <p:clrMapOvr>
+    <a:masterClrMapping/>
+  </p:clrMapOvr>
+</p:sld>
+</file>
+
+<file path=ppt/slides/slide8.xml><?xml version="1.0" encoding="utf-8"?>
+<p:sld xmlns:a="http://schemas.openxmlformats.org/drawingml/2006/main" xmlns:r="http://schemas.openxmlformats.org/officeDocument/2006/relationships" xmlns:p="http://schemas.openxmlformats.org/presentationml/2006/main">
+  <p:cSld>
+    <p:spTree>
+      <p:nvGrpSpPr>
+        <p:cNvPr id="1" name="">
+          <a:extLst>
+            <a:ext uri="{FF2B5EF4-FFF2-40B4-BE49-F238E27FC236}">
+              <a16:creationId xmlns:a16="http://schemas.microsoft.com/office/drawing/2014/main" id="{E2A90FC0-E081-A356-59E2-D0A17AA11DA4}"/>
+            </a:ext>
+          </a:extLst>
+        </p:cNvPr>
+        <p:cNvGrpSpPr/>
+        <p:nvPr/>
+      </p:nvGrpSpPr>
+      <p:grpSpPr>
+        <a:xfrm>
+          <a:off x="0" y="0"/>
+          <a:ext cx="0" cy="0"/>
+          <a:chOff x="0" y="0"/>
+          <a:chExt cx="0" cy="0"/>
+        </a:xfrm>
+      </p:grpSpPr>
+      <p:sp>
+        <p:nvSpPr>
+          <p:cNvPr id="3" name="TextBox 2">
+            <a:extLst>
+              <a:ext uri="{FF2B5EF4-FFF2-40B4-BE49-F238E27FC236}">
+                <a16:creationId xmlns:a16="http://schemas.microsoft.com/office/drawing/2014/main" id="{F02BC94D-629E-7FE2-3BCB-000F476B63BC}"/>
+              </a:ext>
+            </a:extLst>
+          </p:cNvPr>
+          <p:cNvSpPr txBox="1"/>
+          <p:nvPr/>
+        </p:nvSpPr>
+        <p:spPr>
+          <a:xfrm>
+            <a:off x="217714" y="255046"/>
+            <a:ext cx="11756571" cy="355354"/>
+          </a:xfrm>
+          <a:prstGeom prst="rect">
+            <a:avLst/>
+          </a:prstGeom>
+          <a:noFill/>
+        </p:spPr>
+        <p:txBody>
+          <a:bodyPr wrap="square">
+            <a:spAutoFit/>
+          </a:bodyPr>
+          <a:lstStyle/>
+          <a:p>
+            <a:pPr>
+              <a:lnSpc>
+                <a:spcPct val="150000"/>
+              </a:lnSpc>
+              <a:buNone/>
+            </a:pPr>
+            <a:r>
+              <a:rPr kumimoji="0" lang="en-US" altLang="en-US" sz="1300" b="0" i="0" u="none" strike="noStrike" cap="none" normalizeH="0" baseline="0">
+                <a:ln>
+                  <a:noFill/>
+                </a:ln>
+                <a:solidFill>
+                  <a:schemeClr val="tx1"/>
+                </a:solidFill>
+                <a:effectLst/>
+                <a:latin typeface="Arial" panose="020B0604020202020204" pitchFamily="34" charset="0"/>
+              </a:rPr>
+              <a:t>.</a:t>
+            </a:r>
+          </a:p>
+        </p:txBody>
+      </p:sp>
+    </p:spTree>
+    <p:extLst>
+      <p:ext uri="{BB962C8B-B14F-4D97-AF65-F5344CB8AC3E}">
+        <p14:creationId xmlns:p14="http://schemas.microsoft.com/office/powerpoint/2010/main" val="2329161489"/>
+      </p:ext>
+    </p:extLst>
+  </p:cSld>
+  <p:clrMapOvr>
+    <a:masterClrMapping/>
+  </p:clrMapOvr>
+</p:sld>
+</file>
+
+<file path=ppt/slides/slide9.xml><?xml version="1.0" encoding="utf-8"?>
 <p:sld xmlns:a="http://schemas.openxmlformats.org/drawingml/2006/main" xmlns:r="http://schemas.openxmlformats.org/officeDocument/2006/relationships" xmlns:p="http://schemas.openxmlformats.org/presentationml/2006/main">
   <p:cSld>
     <p:spTree>

</xml_diff>